<commit_message>
Improve OTProof docs for mixed audiences
</commit_message>
<xml_diff>
--- a/OTProof_Pitch_Deck.pptx
+++ b/OTProof_Pitch_Deck.pptx
@@ -19,6 +19,7 @@
     <p:sldId id="267" r:id="rId19"/>
     <p:sldId id="268" r:id="rId20"/>
     <p:sldId id="269" r:id="rId21"/>
+    <p:sldId id="270" r:id="rId22"/>
   </p:sldIdLst>
   <p:sldSz cx="12191695" cy="6858000" type="screen4x3"/>
   <p:notesSz cx="6858000" cy="9144000"/>
@@ -515,7 +516,7 @@
           <a:lstStyle/>
           <a:p>
             <a:r>
-              <a:t>Introduce OTProof as a small, evidence-first assurance workflow for vulnerability applicability and remediation review. It starts with an operator-provided CSV or spreadsheet and compares it with approved public advisory information. Deterministic rules make the first applicability classification; a person handles uncertainty, remediation approval, and evidence verification. The demonstration dataset is fictional and the advisory records are real public CISA examples. The application never scans, exploits, or modifies industrial equipment. The aim of this pitch is to validate whether operators need a focused workflow alongside their existing OT security and GRC systems.</a:t>
+              <a:t>Introduce OTProof as a record-checking tool for industrial security work. An operator provides an equipment spreadsheet, and OTProof compares it with public security notices. The screen shows what appears to match, which source it used, and when a person should check missing or unclear details. Engineers and approvers make the consequential decisions. The equipment in the demo is fictional; the CISA notices are real. The application never scans, exploits, queries, or changes industrial equipment. This pitch asks whether operators need a focused review tool alongside the security and audit products they already use.</a:t>
             </a:r>
           </a:p>
         </p:txBody>
@@ -585,7 +586,7 @@
           <a:lstStyle/>
           <a:p>
             <a:r>
-              <a:t>Treat competitors respectfully and accurately. Claroty describes a broad CPS platform across inventory, exposure, protection, and secure access (https://claroty.com/platform). Tenable describes OT asset inventory, vulnerability prioritization, remediation and compliance integrations, and a combination of passive monitoring with vendor-approved active queries (https://www.tenable.com/products/ot-security). Nozomi documentation describes asset discovery, firmware information, and vulnerability assessment (https://technicaldocs.nozominetworks.com/guardian/latest/products/guardian/topics/intro/c_guardian.html). ServiceNow describes risk assessment and issue workflows within its GRC/IRM products (https://www.servicenow.com/docs/r/governance-risk-compliance/grc-risk-management-workspace/grc-risk-overview.html). OTProof has not outperformed these products and may not replace them. The hypothesis to validate is whether a file-first, evidence-centric reconciliation flow is useful in a small team or as a data/workflow connector to existing platforms. Pilot interviews and integration testing will decide.</a:t>
+              <a:t>Existing products may already cover this need. Claroty, Tenable, and Nozomi publicly describe broader industrial security products that include equipment inventory and vulnerability management. ServiceNow and other governance, risk, and compliance tools track organizational reviews, controls, and audit work. OTProof has not been compared head-to-head and has not proved an advantage. The idea to test is whether a small, file-based workflow that keeps source links and engineering decisions together helps a team that does not want another broad platform. Interviews and integration tests with operators should decide whether it fills a real gap. The full product references are listed in the research notes.</a:t>
             </a:r>
           </a:p>
         </p:txBody>
@@ -655,7 +656,7 @@
           <a:lstStyle/>
           <a:p>
             <a:r>
-              <a:t>These are illustrative scenarios, not market research, signed orders, or a revenue forecast. The model assumes three licensed sites per customer at $36,000 per site per year, $25,000 onboarding revenue per new customer, a 78% software gross margin, and 40% services gross margin. The 25-customer case implies 75 licensed sites and $2.70 million recurring ARR. First-year revenue includes onboarding; recurring gross profit excludes services. Sales cycle, procurement, hosting, support, data onboarding and integration costs are not yet measured. Validate the price with target operators and service providers, and derive gross margin from observed deployment and support costs.</a:t>
+              <a:t>These prices are examples to discuss with buyers, not signed orders or a forecast. The model assumes three sites for each customer, a $36,000 annual subscription for each site, and $25,000 one-time setup for each new customer. Annual recurring revenue means the value of subscriptions over a year. Gross margin means the share left after direct costs to deliver the software or setup service. The 25-customer example covers 75 sites and totals $2.70 million in annual subscription income before costs. Sales, hosting, support, data setup, and integration costs are not known yet. Validate prices and costs with operators before making a business forecast.</a:t>
             </a:r>
           </a:p>
         </p:txBody>
@@ -725,7 +726,7 @@
           <a:lstStyle/>
           <a:p>
             <a:r>
-              <a:t>This is a deliberately small synthetic fixture evaluation. It has 14 labeled pairs: four applicable, four not applicable, and six manual verification. All expected outcomes were produced, including every expected abstention, and each output carried source identifiers, URL, and excerpt. The 100% values are not statistically meaningful estimates for unseen products; four positives are too few for that. The approximately 1.01 millisecond benchmark is a single in-process matcher pass over 240 combinations on the development machine. It excludes database and network time. The local model was not run, extraction accuracy is not measured, and no operator time study or savings estimate has been validated.</a:t>
+              <a:t>This test uses only 14 prepared examples: four that should match, four that should not match, and six that lack enough information and should go to review. OTProof returned the expected outcome for all 14. It found all four matching examples and missed none in this small test. These counts do not predict how it will perform on equipment it has never seen. The reported time is one software-only pass over 240 combinations on the development computer; it excludes the database, internet, and people. The AI model was not run, and no review-time or savings study was done.</a:t>
             </a:r>
           </a:p>
         </p:txBody>
@@ -795,7 +796,7 @@
           <a:lstStyle/>
           <a:p>
             <a:r>
-              <a:t>Restate the safety boundary in practical terms. OTProof reads operator-uploaded files and public web sources only. It does not send packets to controllers or install fixes. Uploaded data and advisory pages are treated as untrusted. The optional model is explicitly told not to follow content instructions; structured output is validated against schema and source text. Role checks guard engineering decisions, ticket approvals, and verification. However, the demo token system is not production-grade, the database audit trail can be changed by a privileged database operator, and the tests are not a penetration test. A production pilot requires identity integration, threat modeling, security review, backup and retention controls, and operator approval.</a:t>
+              <a:t>Restate the safety rules clearly. OTProof reads the spreadsheet an operator uploads and public web pages. It does not send requests to equipment or install fixes. Uploaded spreadsheets and notice text are treated as untrusted; embedded instructions cannot tell the AI or application what to do. Only the right human role can record a review, approve a plan, or verify evidence. Still, the demo login is not safe for production, and a database administrator could alter stored history. These tests are not an independent security assessment. Before a real pilot, add company login, plan how records will be protected, review likely attack paths, test backups, and get operator approval.</a:t>
             </a:r>
           </a:p>
         </p:txBody>
@@ -865,7 +866,77 @@
           <a:lstStyle/>
           <a:p>
             <a:r>
-              <a:t>Close with a concrete ask: access to an OT security and engineering team willing to evaluate a controlled pilot using non-sensitive or approved inventory data. The pilot should use multiple vendors, equipment families, and source formats. Engineers should create expected labels before seeing the matcher output, then adjudicate disagreements. Measure missing-data abstention quality, false negatives, false positives, source traceability, minutes per asset/advisory review, onboarding hours, integration requirements, and willingness to pay. Later work includes SSO, stronger audit retention, packaging hardening, and CMMS/GRC integration. This pitch makes no claim of customers, market sizing, savings, or improved risk outcomes. Those are the hypotheses the pilot should test.</a:t>
+              <a:t>Close by asking a water or energy operator and its engineers to review a controlled pilot using approved sample inventory. Include several vendors and equipment families. Ask engineers to label whether each notice applies before showing them OTProof's results, then compare any disagreements. Measure how often OTProof finds a relevant affected product, how often it misses one, how often it asks for human review, how long each review takes, and the effort needed to prepare the data. Later work could add company sign-in, stronger protection for action records, and connections to maintenance or risk tools. No customers, savings, or risk reduction are claimed today; the pilot should test those ideas.</a:t>
+            </a:r>
+          </a:p>
+        </p:txBody>
+      </p:sp>
+      <p:sp>
+        <p:nvSpPr>
+          <p:cNvPr id="4" name="Slide Number Placeholder 3"/>
+          <p:cNvSpPr>
+            <a:spLocks noGrp="1"/>
+          </p:cNvSpPr>
+          <p:nvPr>
+            <p:ph type="sldNum" idx="5" sz="quarter"/>
+          </p:nvPr>
+        </p:nvSpPr>
+        <p:spPr/>
+      </p:sp>
+    </p:spTree>
+  </p:cSld>
+  <p:clrMapOvr>
+    <a:masterClrMapping/>
+  </p:clrMapOvr>
+</p:notes>
+</file>
+
+<file path=ppt/notesSlides/notesSlide15.xml><?xml version="1.0" encoding="utf-8"?>
+<p:notes xmlns:a="http://schemas.openxmlformats.org/drawingml/2006/main" xmlns:p="http://schemas.openxmlformats.org/presentationml/2006/main" xmlns:r="http://schemas.openxmlformats.org/officeDocument/2006/relationships">
+  <p:cSld>
+    <p:spTree>
+      <p:nvGrpSpPr>
+        <p:cNvPr id="1" name=""/>
+        <p:cNvGrpSpPr/>
+        <p:nvPr/>
+      </p:nvGrpSpPr>
+      <p:grpSpPr>
+        <a:xfrm>
+          <a:off x="0" y="0"/>
+          <a:ext cx="0" cy="0"/>
+          <a:chOff x="0" y="0"/>
+          <a:chExt cx="0" cy="0"/>
+        </a:xfrm>
+      </p:grpSpPr>
+      <p:sp>
+        <p:nvSpPr>
+          <p:cNvPr id="2" name="Slide Image Placeholder 1"/>
+          <p:cNvSpPr>
+            <a:spLocks noGrp="1"/>
+          </p:cNvSpPr>
+          <p:nvPr>
+            <p:ph type="sldImg" idx="2"/>
+          </p:nvPr>
+        </p:nvSpPr>
+        <p:spPr/>
+      </p:sp>
+      <p:sp>
+        <p:nvSpPr>
+          <p:cNvPr id="3" name="Notes Placeholder 2"/>
+          <p:cNvSpPr>
+            <a:spLocks noGrp="1"/>
+          </p:cNvSpPr>
+          <p:nvPr>
+            <p:ph type="body" idx="3" sz="quarter"/>
+          </p:nvPr>
+        </p:nvSpPr>
+        <p:spPr/>
+        <p:txBody>
+          <a:bodyPr/>
+          <a:lstStyle/>
+          <a:p>
+            <a:r>
+              <a:t>Use this glossary whenever a term is unfamiliar. Operational technology, or OT, means computers and controllers used to monitor or control physical processes such as water pumping or electricity generation. CISA is the US Cybersecurity and Infrastructure Security Agency, which publishes the advisories used in the demo. CVE is the public identifier assigned to a specific vulnerability. CISA KEV is a public list of vulnerabilities CISA knows have been exploited. A candidate match is a possible link produced by comparing records; it is not an engineering decision. Evidence is a work record, test result, or other reference that supports a human decision. Annual recurring revenue means the yearly value of recurring subscriptions, not profit or guaranteed sales.</a:t>
             </a:r>
           </a:p>
         </p:txBody>
@@ -935,7 +1006,7 @@
           <a:lstStyle/>
           <a:p>
             <a:r>
-              <a:t>The workflow problem is not merely a lack of vulnerability data. Teams need to connect a specific installed asset to a specific published affected product/version and keep the basis for their decision. Inventory records may have old timestamps, vendor spelling differences, or missing firmware. Advisories may use a different product family name or a nuanced version boundary. A loose name match can create noise, while a missing version can block a safe conclusion. NIST SP 800-82 Revision 3, the current published final guide used here, emphasizes accurate inventory details and careful evaluation of automated OT collection methods. OTProof begins from records operators already have.</a:t>
+              <a:t>The challenge is connecting one installed asset to one public notice and keeping the reason for the decision. The equipment list may be old, spell the maker differently, or omit the software version. The notice may describe the same product family with different wording. A loose name match creates false alarms; missing version details make a confident conclusion impossible. NIST, the U.S. National Institute of Standards and Technology, recommends accurate equipment records in its published OT security guide, Revision 3. OTProof starts from the operator's existing files and leaves the industrial network alone.</a:t>
             </a:r>
           </a:p>
         </p:txBody>
@@ -1005,7 +1076,7 @@
           <a:lstStyle/>
           <a:p>
             <a:r>
-              <a:t>OT environments have availability, reliability, and safety requirements that shape how security work is performed. OTProof is deliberately not an asset discovery product and does not ask an operator to scan or modify controllers, gateways, HMIs, or supervisory systems. The user supplies the inventory, and the service retrieves public advisory information. NIST lists Revision 3 as final and Revision 4 as a draft from September 2026, so these materials cite Revision 3 as final. The product's role is narrower: produce an explainable candidate and leave technical applicability, change planning, approval, and verification with authorized staff.</a:t>
+              <a:t>Water, power, and other essential services depend on equipment that must keep running reliably and safely. A public notice does not automatically mean a local device should be patched. OTProof does not discover equipment, send network queries, or change controllers, gateway computers, operator screens, or supervisory systems. The operator supplies the equipment list, and OTProof retrieves public notices. NIST's Revision 3 is the published final OT guide. Revision 4 is a draft, so this project does not describe it as final. Authorized staff decide what applies, what work is safe, and whether evidence is sufficient.</a:t>
             </a:r>
           </a:p>
         </p:txBody>
@@ -1075,7 +1146,7 @@
           <a:lstStyle/>
           <a:p>
             <a:r>
-              <a:t>Walk through the six steps. First, load a CSV or XLSX inventory and validate required fields, identifiers, and workbook type. Second, import CISA ICS or KEV data, an NVD CVE record, or an approved vendor bulletin; offline fixtures remain available. Third, run deterministic matching and inspect every source and inventory field. Fourth, an engineer or reviewer records an applicability decision and rationale. Fifth, a remediation action can be proposed and approved by a separate approver. Sixth, evidence is attached and verified against a selected record. The assurance report exports that chain. A generated summary or an attached evidence note cannot independently close a finding.</a:t>
+              <a:t>Walk through the six steps. First, load an equipment spreadsheet and check its required fields. Second, load a public notice from CISA or NIST, or an approved vendor website; the fixed demo examples work without internet access. Third, compare maker, product, model, and version details and open the source link. Fourth, a reviewer records whether the notice fits and explains why. Fifth, an engineer proposes a work plan and a separate approver accepts or rejects it. Sixth, the team attaches a change or test record and an approver checks it. The report saves this history. A generated summary or attached note cannot close the finding by itself.</a:t>
             </a:r>
           </a:p>
         </p:txBody>
@@ -1145,7 +1216,7 @@
           <a:lstStyle/>
           <a:p>
             <a:r>
-              <a:t>Use the fixture example to show the three labels. CV-HMI-001 records FactoryTalk View Site Edition version 13.0.0. The matcher normalizes a curated product alias and numeric trailing zero, then compares the installed version to CISA's affected statement for FactoryTalk View SE version 13.0. CV-HMI-002 uses the same product at 14.0, which is outside the exact version statement. CV-HMI-005 has no firmware version; the correct result is manual verification because product identity alone is insufficient. The advisory is genuine and its CISA URL and publication/update dates are included. The utility and asset records are fictional.</a:t>
+              <a:t>Use the three fictional assets to explain the outcomes. CV-HMI-001 lists FactoryTalk View Site Edition version 13.0.0. The CISA notice names version 13.0, so OTProof shows a possible match and links the original notice. CV-HMI-002 lists version 14.0, which is outside that exact statement. CV-HMI-005 does not list a version, so OTProof asks an engineer to check instead of guessing. The notice is real, and its publication and update dates are retained. The utility, assets, and work records are fictional. A possible match is a screening result, not an engineering decision or a claim that a device is vulnerable in practice.</a:t>
             </a:r>
           </a:p>
         </p:txBody>
@@ -1215,7 +1286,7 @@
           <a:lstStyle/>
           <a:p>
             <a:r>
-              <a:t>The matcher is intentionally conservative. It normalizes case and punctuation and applies a short, curated alias map. It does not use Sentence Transformers or an embedding score as a vulnerability verdict. Numeric dotted versions are compared against supported operators. Constraints within one CPE match are conjunctive; alternate product candidates remain alternatives. Missing firmware, a stale inventory verification date, unknown model, duplicate identity, unsupported suffixes, or compound NVD configuration logic produce a manual-review outcome. Every result keeps the inventory values, advisory identifier, source URL, excerpt, and explanation. Product and model catalogs still need wider field validation.</a:t>
+              <a:t>The matching rules are designed to avoid guesses. OTProof recognizes only a small, reviewed list of spelling variations. It then compares the inventory version with the version or range printed in the notice. It does not decide from a similar-sounding product name. If the version is missing, the inventory is old, two records may describe the same device, or the source uses a format the software cannot read, the result goes to an engineer. Every result keeps the values and source text used to reach it. The current product and model list is narrow and needs testing with more operators and equipment families.</a:t>
             </a:r>
           </a:p>
         </p:txBody>
@@ -1285,7 +1356,7 @@
           <a:lstStyle/>
           <a:p>
             <a:r>
-              <a:t>AI is a small, optional component, not the core decision maker. A local Ollama-compatible server can propose structured extraction and a plain-language summary. The prompt identifies advisory content as untrusted and says to ignore embedded commands. Pydantic validates output shape, and cited identifiers, product/version/mitigation strings, and quotes are checked against the source. These checks reduce unsupported output but cannot prove summary completeness or correctness. The application labels the result suggestion-only. The model was not installed or run during this MVP validation, and no extraction accuracy benefit is claimed. A future evaluation should compare blinded model outputs against engineer-labeled source excerpts and deterministic extraction baselines.</a:t>
+              <a:t>AI is optional and helps with reading, not deciding. A local model can suggest product names, versions, vulnerability IDs, mitigations, and a short summary from a notice. The output has required fields, and quoted details are checked against the original text. This catches some unsupported claims, but it cannot prove that a summary is complete or correct. The application labels AI text as a suggestion and never lets it set applicability, approve a work plan, or close a finding. No model was installed or run for this evaluation, so AI quality has not been measured. A later test should compare its suggestions with source excerpts labeled by engineers.</a:t>
             </a:r>
           </a:p>
         </p:txBody>
@@ -1355,7 +1426,7 @@
           <a:lstStyle/>
           <a:p>
             <a:r>
-              <a:t>Describe the technology choices as an implementation, not a production certification. The UI is React and TypeScript. FastAPI validates routes and Pydantic schemas. SQLAlchemy sits over PostgreSQL for deployment and SQLite for quick local use. Alembic tracks schema migrations. Source adapters store cached payloads and metadata; the matcher produces traceable findings; workflow services record decisions; ReportLab exports PDF. Docker Compose packages the services, although a Docker daemon was unavailable in the build environment, so startup was not verified. The optional LLM calls a local inference endpoint. No service connects to an OT address range or equipment protocol.</a:t>
+              <a:t>Explain the drawing from left to right. The operator supplies an equipment spreadsheet, and the application retrieves public notices. One service checks the inputs, compares product and version details, and saves each result in a database. The dashboard shows the results; a report carries the source and human decisions. The implementation uses React for the web screen, FastAPI for the service, and PostgreSQL or SQLite for saved records. These are implementation choices, not a production certification. Docker packaging is included, but the Docker service was unavailable here, so a container startup was not verified. There is no connection to an industrial network.</a:t>
             </a:r>
           </a:p>
         </p:txBody>
@@ -1425,7 +1496,7 @@
           <a:lstStyle/>
           <a:p>
             <a:r>
-              <a:t>Show that decisions are distinct records. A reviewer records whether the advisory applies and why. An engineer proposes a mitigation with an owner and date, and a separate approver can approve or reject that plan. The engineer attaches evidence; the approver verifies a selected evidence record and explains the decision. The application hashes evidence text content and records the actor and role. Hashing only preserves a comparison value; it does not make the database immutable or prove the source document is authentic. The demo workflow uses visible local tokens for convenience and is not a production authentication setup. In a real deployment, use managed identities and protected audit storage.</a:t>
+              <a:t>Show that the people do different jobs. The reviewer records whether the notice fits the equipment and why. The engineer proposes a plan; an approver accepts or rejects it. After work, the engineer adds a record or reference, and an approver checks that evidence. The application saves who did what and when. It also calculates a digital fingerprint from evidence text so a later copy can be compared. A fingerprint does not prove the original record is true or prevent a database administrator from changing it. Demo passwords are visible and only for this fictional demo. Real use needs company login and protected records.</a:t>
             </a:r>
           </a:p>
         </p:txBody>
@@ -4628,7 +4699,7 @@
               </a:defRPr>
             </a:pPr>
             <a:r>
-              <a:t>Evidence-first vulnerability applicability and remediation assurance for industrial assets</a:t>
+              <a:t>Check which public security notices may affect industrial equipment, then keep the human review and evidence together.</a:t>
             </a:r>
           </a:p>
         </p:txBody>
@@ -4664,7 +4735,7 @@
               </a:defRPr>
             </a:pPr>
             <a:r>
-              <a:t>•  Reconcile an operator inventory with public ICS advisories</a:t>
+              <a:t>•  Compare the equipment list with public industrial security notices</a:t>
             </a:r>
           </a:p>
         </p:txBody>
@@ -4700,7 +4771,7 @@
               </a:defRPr>
             </a:pPr>
             <a:r>
-              <a:t>•  Show exact product/version evidence and uncertainty</a:t>
+              <a:t>•  Show what matched, what did not, and what is unknown</a:t>
             </a:r>
           </a:p>
         </p:txBody>
@@ -4736,7 +4807,7 @@
               </a:defRPr>
             </a:pPr>
             <a:r>
-              <a:t>•  Keep engineering and approval decisions human-owned</a:t>
+              <a:t>•  People decide and approve any work</a:t>
             </a:r>
           </a:p>
         </p:txBody>
@@ -4923,7 +4994,7 @@
               </a:defRPr>
             </a:pPr>
             <a:r>
-              <a:t>No OT interaction in this MVP</a:t>
+              <a:t>No contact with industrial equipment</a:t>
             </a:r>
           </a:p>
         </p:txBody>
@@ -5294,7 +5365,7 @@
               </a:defRPr>
             </a:pPr>
             <a:r>
-              <a:t>Positioning: complement an established OT security landscape</a:t>
+              <a:t>Where OTProof could fit</a:t>
             </a:r>
           </a:p>
         </p:txBody>
@@ -5330,7 +5401,7 @@
               </a:defRPr>
             </a:pPr>
             <a:r>
-              <a:t>Broad platforms already offer inventory and exposure workflows; the proposed wedge is narrower.</a:t>
+              <a:t>Existing security platforms may already help. OTProof’s possible role is a focused review and evidence workflow.</a:t>
             </a:r>
           </a:p>
         </p:txBody>
@@ -5445,7 +5516,7 @@
               </a:defRPr>
             </a:pPr>
             <a:r>
-              <a:t>Claroty, Tenable, and Nozomi describe broad OT visibility and risk products</a:t>
+              <a:t>OT security platforms offer asset visibility and vulnerability management</a:t>
             </a:r>
           </a:p>
         </p:txBody>
@@ -5560,7 +5631,7 @@
               </a:defRPr>
             </a:pPr>
             <a:r>
-              <a:t>GRC / IRM platforms manage enterprise risk, controls, and audit workflow</a:t>
+              <a:t>Risk and compliance tools track controls, reviews, and audit records</a:t>
             </a:r>
           </a:p>
         </p:txBody>
@@ -5675,7 +5746,7 @@
               </a:defRPr>
             </a:pPr>
             <a:r>
-              <a:t>Test if source-linked review fills a process gap or integrates cleanly</a:t>
+              <a:t>Test whether this focused workflow fills a real gap or connects to them</a:t>
             </a:r>
           </a:p>
         </p:txBody>
@@ -6178,7 +6249,7 @@
               </a:defRPr>
             </a:pPr>
             <a:r>
-              <a:t>SERVICE / GRC</a:t>
+              <a:t>RISK / AUDIT</a:t>
             </a:r>
           </a:p>
         </p:txBody>
@@ -6420,7 +6491,7 @@
               </a:defRPr>
             </a:pPr>
             <a:r>
-              <a:t>A site license plus deployment and assurance services</a:t>
+              <a:t>A possible per-site subscription model</a:t>
             </a:r>
           </a:p>
         </p:txBody>
@@ -6456,7 +6527,7 @@
               </a:defRPr>
             </a:pPr>
             <a:r>
-              <a:t>Start with a transparent per-site hypothesis, then validate effort and willingness to pay.</a:t>
+              <a:t>The example prices below are assumptions to test with buyers, not sales or a forecast.</a:t>
             </a:r>
           </a:p>
         </p:txBody>
@@ -6571,7 +6642,7 @@
               </a:defRPr>
             </a:pPr>
             <a:r>
-              <a:t>Illustrative license: $36,000 per site per year</a:t>
+              <a:t>Example annual license: $36,000 per site</a:t>
             </a:r>
           </a:p>
         </p:txBody>
@@ -6686,7 +6757,7 @@
               </a:defRPr>
             </a:pPr>
             <a:r>
-              <a:t>Illustrative onboarding: $25,000 per new customer</a:t>
+              <a:t>Example one-time setup: $25,000 per new customer</a:t>
             </a:r>
           </a:p>
         </p:txBody>
@@ -6801,7 +6872,7 @@
               </a:defRPr>
             </a:pPr>
             <a:r>
-              <a:t>Enterprise tiers, integrations, and ongoing review services are options</a:t>
+              <a:t>Other options: enterprise plans, integrations, and review services</a:t>
             </a:r>
           </a:p>
         </p:txBody>
@@ -6952,7 +7023,7 @@
               </a:defRPr>
             </a:pPr>
             <a:r>
-              <a:t>$108k ARR</a:t>
+              <a:t>$108k / year</a:t>
             </a:r>
           </a:p>
         </p:txBody>
@@ -7067,7 +7138,7 @@
               </a:defRPr>
             </a:pPr>
             <a:r>
-              <a:t>$540k ARR</a:t>
+              <a:t>$540k / year</a:t>
             </a:r>
           </a:p>
         </p:txBody>
@@ -7182,7 +7253,7 @@
               </a:defRPr>
             </a:pPr>
             <a:r>
-              <a:t>$1.08m ARR</a:t>
+              <a:t>$1.08m / year</a:t>
             </a:r>
           </a:p>
         </p:txBody>
@@ -7297,7 +7368,7 @@
               </a:defRPr>
             </a:pPr>
             <a:r>
-              <a:t>$2.70m ARR</a:t>
+              <a:t>$2.70m / year</a:t>
             </a:r>
           </a:p>
         </p:txBody>
@@ -7467,7 +7538,7 @@
               </a:defRPr>
             </a:pPr>
             <a:r>
-              <a:t>MVP baseline: correct on a small, explicit fixture set</a:t>
+              <a:t>What the test shows—and what it does not</a:t>
             </a:r>
           </a:p>
         </p:txBody>
@@ -7503,7 +7574,7 @@
               </a:defRPr>
             </a:pPr>
             <a:r>
-              <a:t>The results show the code follows the labels supplied; they do not estimate field accuracy.</a:t>
+              <a:t>The software matched this small set of prepared examples; the result does not predict field accuracy.</a:t>
             </a:r>
           </a:p>
         </p:txBody>
@@ -7618,7 +7689,7 @@
               </a:defRPr>
             </a:pPr>
             <a:r>
-              <a:t>14/14 labeled cases matched expected outcomes</a:t>
+              <a:t>All 14 labeled test cases matched their expected outcome</a:t>
             </a:r>
           </a:p>
         </p:txBody>
@@ -7733,7 +7804,7 @@
               </a:defRPr>
             </a:pPr>
             <a:r>
-              <a:t>4 applicable cases: 100% fixture precision/recall, 0 fixture false negatives</a:t>
+              <a:t>All 4 affected examples were found; none were missed in this set</a:t>
             </a:r>
           </a:p>
         </p:txBody>
@@ -7848,7 +7919,7 @@
               </a:defRPr>
             </a:pPr>
             <a:r>
-              <a:t>6/6 uncertainty cases abstained; 14/14 outputs had source traceability</a:t>
+              <a:t>All 6 uncertain examples went to human review; all results link to sources</a:t>
             </a:r>
           </a:p>
         </p:txBody>
@@ -8042,7 +8113,7 @@
               </a:defRPr>
             </a:pPr>
             <a:r>
-              <a:t>labels</a:t>
+              <a:t>tests passed</a:t>
             </a:r>
           </a:p>
         </p:txBody>
@@ -8157,7 +8228,7 @@
               </a:defRPr>
             </a:pPr>
             <a:r>
-              <a:t>applicable recall</a:t>
+              <a:t>affected cases found</a:t>
             </a:r>
           </a:p>
         </p:txBody>
@@ -8272,7 +8343,7 @@
               </a:defRPr>
             </a:pPr>
             <a:r>
-              <a:t>abstain</a:t>
+              <a:t>sent to review</a:t>
             </a:r>
           </a:p>
         </p:txBody>
@@ -8387,7 +8458,7 @@
               </a:defRPr>
             </a:pPr>
             <a:r>
-              <a:t>traceable</a:t>
+              <a:t>sources linked</a:t>
             </a:r>
           </a:p>
         </p:txBody>
@@ -8593,7 +8664,7 @@
               </a:defRPr>
             </a:pPr>
             <a:r>
-              <a:t>Trust boundaries are product requirements</a:t>
+              <a:t>Safety and trust boundaries</a:t>
             </a:r>
           </a:p>
         </p:txBody>
@@ -8629,7 +8700,7 @@
               </a:defRPr>
             </a:pPr>
             <a:r>
-              <a:t>Keep OT interactions passive and offline in the MVP, and reserve consequential decisions for people.</a:t>
+              <a:t>The app reads files and public notices. It never contacts or changes industrial equipment.</a:t>
             </a:r>
           </a:p>
         </p:txBody>
@@ -8744,7 +8815,7 @@
               </a:defRPr>
             </a:pPr>
             <a:r>
-              <a:t>No scan, exploit, device query, or configuration modification</a:t>
+              <a:t>No device scan, remote query, exploit, or configuration change</a:t>
             </a:r>
           </a:p>
         </p:txBody>
@@ -8859,7 +8930,7 @@
               </a:defRPr>
             </a:pPr>
             <a:r>
-              <a:t>Treat uploads and advisory text as untrusted content</a:t>
+              <a:t>Uploaded files and notice text are treated as untrusted input</a:t>
             </a:r>
           </a:p>
         </p:txBody>
@@ -8974,7 +9045,7 @@
               </a:defRPr>
             </a:pPr>
             <a:r>
-              <a:t>Approval and verification require role-gated human action</a:t>
+              <a:t>People approve work and check evidence before closing a finding</a:t>
             </a:r>
           </a:p>
         </p:txBody>
@@ -9283,7 +9354,7 @@
               </a:defRPr>
             </a:pPr>
             <a:r>
-              <a:t>Evidence and audit trail</a:t>
+              <a:t>Evidence and action history</a:t>
             </a:r>
           </a:p>
         </p:txBody>
@@ -9362,7 +9433,7 @@
               </a:defRPr>
             </a:pPr>
             <a:r>
-              <a:t>Production auth still required</a:t>
+              <a:t>Company login needed for real use</a:t>
             </a:r>
           </a:p>
         </p:txBody>
@@ -9398,7 +9469,7 @@
               </a:defRPr>
             </a:pPr>
             <a:r>
-              <a:t>Threat model, identity, immutable audit, and security testing remain pilot work.</a:t>
+              <a:t>Security review, company login, and protected action records remain future work.</a:t>
             </a:r>
           </a:p>
         </p:txBody>
@@ -9532,7 +9603,7 @@
               </a:defRPr>
             </a:pPr>
             <a:r>
-              <a:t>Next: validate with OT engineers and real workflow constraints</a:t>
+              <a:t>Next: test with operators and engineers</a:t>
             </a:r>
           </a:p>
         </p:txBody>
@@ -9568,7 +9639,7 @@
               </a:defRPr>
             </a:pPr>
             <a:r>
-              <a:t>The next milestone is evidence of usefulness, not a larger feature checklist.</a:t>
+              <a:t>The next step is to learn whether this helps real teams and fits their existing process.</a:t>
             </a:r>
           </a:p>
         </p:txBody>
@@ -9683,7 +9754,7 @@
               </a:defRPr>
             </a:pPr>
             <a:r>
-              <a:t>Recruit 3–5 operator or managed-service design partners</a:t>
+              <a:t>Invite 3–5 operators or service providers to try a controlled pilot</a:t>
             </a:r>
           </a:p>
         </p:txBody>
@@ -9798,7 +9869,7 @@
               </a:defRPr>
             </a:pPr>
             <a:r>
-              <a:t>Build a blinded, multi-vendor adjudication set with engineers</a:t>
+              <a:t>Ask engineers to label cases before seeing the software’s result</a:t>
             </a:r>
           </a:p>
         </p:txBody>
@@ -9913,7 +9984,7 @@
               </a:defRPr>
             </a:pPr>
             <a:r>
-              <a:t>Measure false negatives, abstentions, review time, and onboarding effort</a:t>
+              <a:t>Measure missed cases, human-review rate, time, and setup effort</a:t>
             </a:r>
           </a:p>
         </p:txBody>
@@ -10143,7 +10214,7 @@
               </a:defRPr>
             </a:pPr>
             <a:r>
-              <a:t>Broaden source/vendor coverage</a:t>
+              <a:t>Add more vendors and sources</a:t>
             </a:r>
           </a:p>
         </p:txBody>
@@ -10222,7 +10293,7 @@
               </a:defRPr>
             </a:pPr>
             <a:r>
-              <a:t>Add SSO and durable audit</a:t>
+              <a:t>Add company sign-in and protected audit records</a:t>
             </a:r>
           </a:p>
         </p:txBody>
@@ -10301,7 +10372,7 @@
               </a:defRPr>
             </a:pPr>
             <a:r>
-              <a:t>Test CMMS / GRC connectors</a:t>
+              <a:t>Connect to maintenance and risk systems if users need it</a:t>
             </a:r>
           </a:p>
         </p:txBody>
@@ -10338,6 +10409,1139 @@
             </a:pPr>
             <a:r>
               <a:t>No customer interviews, paid pilots, or measured savings are claimed yet.</a:t>
+            </a:r>
+          </a:p>
+        </p:txBody>
+      </p:sp>
+    </p:spTree>
+  </p:cSld>
+  <p:clrMapOvr>
+    <a:masterClrMapping/>
+  </p:clrMapOvr>
+</p:sld>
+</file>
+
+<file path=ppt/slides/slide15.xml><?xml version="1.0" encoding="utf-8"?>
+<p:sld xmlns:a="http://schemas.openxmlformats.org/drawingml/2006/main" xmlns:p="http://schemas.openxmlformats.org/presentationml/2006/main" xmlns:r="http://schemas.openxmlformats.org/officeDocument/2006/relationships">
+  <p:cSld>
+    <p:bg>
+      <p:bgPr>
+        <a:solidFill>
+          <a:srgbClr val="F3F7F6"/>
+        </a:solidFill>
+        <a:effectLst/>
+      </p:bgPr>
+    </p:bg>
+    <p:spTree>
+      <p:nvGrpSpPr>
+        <p:cNvPr id="1" name=""/>
+        <p:cNvGrpSpPr/>
+        <p:nvPr/>
+      </p:nvGrpSpPr>
+      <p:grpSpPr/>
+      <p:sp>
+        <p:nvSpPr>
+          <p:cNvPr id="2" name="TextBox 1"/>
+          <p:cNvSpPr txBox="1"/>
+          <p:nvPr/>
+        </p:nvSpPr>
+        <p:spPr>
+          <a:xfrm>
+            <a:off x="658368" y="310896"/>
+            <a:ext cx="4572000" cy="201168"/>
+          </a:xfrm>
+          <a:prstGeom prst="rect">
+            <a:avLst/>
+          </a:prstGeom>
+          <a:noFill/>
+        </p:spPr>
+        <p:txBody>
+          <a:bodyPr wrap="square" lIns="0" rIns="0" tIns="0" bIns="0">
+            <a:spAutoFit/>
+          </a:bodyPr>
+          <a:lstStyle/>
+          <a:p>
+            <a:pPr algn="l">
+              <a:defRPr sz="800" b="1">
+                <a:solidFill>
+                  <a:srgbClr val="25A99A"/>
+                </a:solidFill>
+                <a:latin typeface="Aptos"/>
+              </a:defRPr>
+            </a:pPr>
+            <a:r>
+              <a:t>OTPROOF  /  EUREKA HACKATHON</a:t>
+            </a:r>
+          </a:p>
+        </p:txBody>
+      </p:sp>
+      <p:sp>
+        <p:nvSpPr>
+          <p:cNvPr id="3" name="TextBox 2"/>
+          <p:cNvSpPr txBox="1"/>
+          <p:nvPr/>
+        </p:nvSpPr>
+        <p:spPr>
+          <a:xfrm>
+            <a:off x="11082528" y="310896"/>
+            <a:ext cx="411480" cy="201168"/>
+          </a:xfrm>
+          <a:prstGeom prst="rect">
+            <a:avLst/>
+          </a:prstGeom>
+          <a:noFill/>
+        </p:spPr>
+        <p:txBody>
+          <a:bodyPr wrap="square" lIns="0" rIns="0" tIns="0" bIns="0">
+            <a:spAutoFit/>
+          </a:bodyPr>
+          <a:lstStyle/>
+          <a:p>
+            <a:pPr algn="r">
+              <a:defRPr sz="800" b="1">
+                <a:solidFill>
+                  <a:srgbClr val="63777C"/>
+                </a:solidFill>
+                <a:latin typeface="Aptos"/>
+              </a:defRPr>
+            </a:pPr>
+            <a:r>
+              <a:t>15</a:t>
+            </a:r>
+          </a:p>
+        </p:txBody>
+      </p:sp>
+      <p:sp>
+        <p:nvSpPr>
+          <p:cNvPr id="4" name="TextBox 3"/>
+          <p:cNvSpPr txBox="1"/>
+          <p:nvPr/>
+        </p:nvSpPr>
+        <p:spPr>
+          <a:xfrm>
+            <a:off x="658368" y="704088"/>
+            <a:ext cx="10881360" cy="502920"/>
+          </a:xfrm>
+          <a:prstGeom prst="rect">
+            <a:avLst/>
+          </a:prstGeom>
+          <a:noFill/>
+        </p:spPr>
+        <p:txBody>
+          <a:bodyPr wrap="square" lIns="0" rIns="0" tIns="0" bIns="0">
+            <a:spAutoFit/>
+          </a:bodyPr>
+          <a:lstStyle/>
+          <a:p>
+            <a:pPr algn="l">
+              <a:defRPr sz="2500" b="1">
+                <a:solidFill>
+                  <a:srgbClr val="122430"/>
+                </a:solidFill>
+                <a:latin typeface="Aptos Display"/>
+              </a:defRPr>
+            </a:pPr>
+            <a:r>
+              <a:t>Plain-language glossary</a:t>
+            </a:r>
+          </a:p>
+        </p:txBody>
+      </p:sp>
+      <p:sp>
+        <p:nvSpPr>
+          <p:cNvPr id="5" name="TextBox 4"/>
+          <p:cNvSpPr txBox="1"/>
+          <p:nvPr/>
+        </p:nvSpPr>
+        <p:spPr>
+          <a:xfrm>
+            <a:off x="676656" y="1261872"/>
+            <a:ext cx="10835640" cy="329184"/>
+          </a:xfrm>
+          <a:prstGeom prst="rect">
+            <a:avLst/>
+          </a:prstGeom>
+          <a:noFill/>
+        </p:spPr>
+        <p:txBody>
+          <a:bodyPr wrap="square" lIns="0" rIns="0" tIns="0" bIns="0">
+            <a:spAutoFit/>
+          </a:bodyPr>
+          <a:lstStyle/>
+          <a:p>
+            <a:pPr algn="l">
+              <a:defRPr sz="1100" b="0">
+                <a:solidFill>
+                  <a:srgbClr val="63777C"/>
+                </a:solidFill>
+                <a:latin typeface="Aptos"/>
+              </a:defRPr>
+            </a:pPr>
+            <a:r>
+              <a:t>A quick translation of the terms used in this presentation.</a:t>
+            </a:r>
+          </a:p>
+        </p:txBody>
+      </p:sp>
+      <p:sp>
+        <p:nvSpPr>
+          <p:cNvPr id="6" name="Rounded Rectangle 5"/>
+          <p:cNvSpPr/>
+          <p:nvPr/>
+        </p:nvSpPr>
+        <p:spPr>
+          <a:xfrm>
+            <a:off x="704088" y="1965960"/>
+            <a:ext cx="338328" cy="338328"/>
+          </a:xfrm>
+          <a:prstGeom prst="roundRect">
+            <a:avLst/>
+          </a:prstGeom>
+          <a:solidFill>
+            <a:srgbClr val="25A99A"/>
+          </a:solidFill>
+          <a:ln>
+            <a:noFill/>
+          </a:ln>
+        </p:spPr>
+        <p:style>
+          <a:lnRef idx="1">
+            <a:schemeClr val="accent1"/>
+          </a:lnRef>
+          <a:fillRef idx="3">
+            <a:schemeClr val="accent1"/>
+          </a:fillRef>
+          <a:effectRef idx="2">
+            <a:schemeClr val="accent1"/>
+          </a:effectRef>
+          <a:fontRef idx="minor">
+            <a:schemeClr val="lt1"/>
+          </a:fontRef>
+        </p:style>
+        <p:txBody>
+          <a:bodyPr rtlCol="0" anchor="ctr"/>
+          <a:lstStyle/>
+          <a:p>
+            <a:pPr algn="ctr"/>
+          </a:p>
+        </p:txBody>
+      </p:sp>
+      <p:sp>
+        <p:nvSpPr>
+          <p:cNvPr id="7" name="TextBox 6"/>
+          <p:cNvSpPr txBox="1"/>
+          <p:nvPr/>
+        </p:nvSpPr>
+        <p:spPr>
+          <a:xfrm>
+            <a:off x="704088" y="2020824"/>
+            <a:ext cx="338328" cy="182880"/>
+          </a:xfrm>
+          <a:prstGeom prst="rect">
+            <a:avLst/>
+          </a:prstGeom>
+          <a:noFill/>
+        </p:spPr>
+        <p:txBody>
+          <a:bodyPr wrap="square" lIns="0" rIns="0" tIns="0" bIns="0">
+            <a:spAutoFit/>
+          </a:bodyPr>
+          <a:lstStyle/>
+          <a:p>
+            <a:pPr algn="ctr">
+              <a:defRPr sz="800" b="1">
+                <a:solidFill>
+                  <a:srgbClr val="FFFFFF"/>
+                </a:solidFill>
+                <a:latin typeface="Aptos"/>
+              </a:defRPr>
+            </a:pPr>
+            <a:r>
+              <a:t>01</a:t>
+            </a:r>
+          </a:p>
+        </p:txBody>
+      </p:sp>
+      <p:sp>
+        <p:nvSpPr>
+          <p:cNvPr id="8" name="TextBox 7"/>
+          <p:cNvSpPr txBox="1"/>
+          <p:nvPr/>
+        </p:nvSpPr>
+        <p:spPr>
+          <a:xfrm>
+            <a:off x="1243584" y="1929384"/>
+            <a:ext cx="5074920" cy="777240"/>
+          </a:xfrm>
+          <a:prstGeom prst="rect">
+            <a:avLst/>
+          </a:prstGeom>
+          <a:noFill/>
+        </p:spPr>
+        <p:txBody>
+          <a:bodyPr wrap="square" lIns="0" rIns="0" tIns="0" bIns="0">
+            <a:spAutoFit/>
+          </a:bodyPr>
+          <a:lstStyle/>
+          <a:p>
+            <a:pPr algn="l">
+              <a:defRPr sz="1500" b="1">
+                <a:solidFill>
+                  <a:srgbClr val="18313A"/>
+                </a:solidFill>
+                <a:latin typeface="Aptos"/>
+              </a:defRPr>
+            </a:pPr>
+            <a:r>
+              <a:t>Asset: a device or software record in the operator’s equipment list</a:t>
+            </a:r>
+          </a:p>
+        </p:txBody>
+      </p:sp>
+      <p:sp>
+        <p:nvSpPr>
+          <p:cNvPr id="9" name="Rounded Rectangle 8"/>
+          <p:cNvSpPr/>
+          <p:nvPr/>
+        </p:nvSpPr>
+        <p:spPr>
+          <a:xfrm>
+            <a:off x="704088" y="2990088"/>
+            <a:ext cx="338328" cy="338328"/>
+          </a:xfrm>
+          <a:prstGeom prst="roundRect">
+            <a:avLst/>
+          </a:prstGeom>
+          <a:solidFill>
+            <a:srgbClr val="25A99A"/>
+          </a:solidFill>
+          <a:ln>
+            <a:noFill/>
+          </a:ln>
+        </p:spPr>
+        <p:style>
+          <a:lnRef idx="1">
+            <a:schemeClr val="accent1"/>
+          </a:lnRef>
+          <a:fillRef idx="3">
+            <a:schemeClr val="accent1"/>
+          </a:fillRef>
+          <a:effectRef idx="2">
+            <a:schemeClr val="accent1"/>
+          </a:effectRef>
+          <a:fontRef idx="minor">
+            <a:schemeClr val="lt1"/>
+          </a:fontRef>
+        </p:style>
+        <p:txBody>
+          <a:bodyPr rtlCol="0" anchor="ctr"/>
+          <a:lstStyle/>
+          <a:p>
+            <a:pPr algn="ctr"/>
+          </a:p>
+        </p:txBody>
+      </p:sp>
+      <p:sp>
+        <p:nvSpPr>
+          <p:cNvPr id="10" name="TextBox 9"/>
+          <p:cNvSpPr txBox="1"/>
+          <p:nvPr/>
+        </p:nvSpPr>
+        <p:spPr>
+          <a:xfrm>
+            <a:off x="704088" y="3044952"/>
+            <a:ext cx="338328" cy="182880"/>
+          </a:xfrm>
+          <a:prstGeom prst="rect">
+            <a:avLst/>
+          </a:prstGeom>
+          <a:noFill/>
+        </p:spPr>
+        <p:txBody>
+          <a:bodyPr wrap="square" lIns="0" rIns="0" tIns="0" bIns="0">
+            <a:spAutoFit/>
+          </a:bodyPr>
+          <a:lstStyle/>
+          <a:p>
+            <a:pPr algn="ctr">
+              <a:defRPr sz="800" b="1">
+                <a:solidFill>
+                  <a:srgbClr val="FFFFFF"/>
+                </a:solidFill>
+                <a:latin typeface="Aptos"/>
+              </a:defRPr>
+            </a:pPr>
+            <a:r>
+              <a:t>02</a:t>
+            </a:r>
+          </a:p>
+        </p:txBody>
+      </p:sp>
+      <p:sp>
+        <p:nvSpPr>
+          <p:cNvPr id="11" name="TextBox 10"/>
+          <p:cNvSpPr txBox="1"/>
+          <p:nvPr/>
+        </p:nvSpPr>
+        <p:spPr>
+          <a:xfrm>
+            <a:off x="1243584" y="2953512"/>
+            <a:ext cx="5074920" cy="777240"/>
+          </a:xfrm>
+          <a:prstGeom prst="rect">
+            <a:avLst/>
+          </a:prstGeom>
+          <a:noFill/>
+        </p:spPr>
+        <p:txBody>
+          <a:bodyPr wrap="square" lIns="0" rIns="0" tIns="0" bIns="0">
+            <a:spAutoFit/>
+          </a:bodyPr>
+          <a:lstStyle/>
+          <a:p>
+            <a:pPr algn="l">
+              <a:defRPr sz="1500" b="0">
+                <a:solidFill>
+                  <a:srgbClr val="18313A"/>
+                </a:solidFill>
+                <a:latin typeface="Aptos"/>
+              </a:defRPr>
+            </a:pPr>
+            <a:r>
+              <a:t>Advisory: a public security notice about a product weakness</a:t>
+            </a:r>
+          </a:p>
+        </p:txBody>
+      </p:sp>
+      <p:sp>
+        <p:nvSpPr>
+          <p:cNvPr id="12" name="Rounded Rectangle 11"/>
+          <p:cNvSpPr/>
+          <p:nvPr/>
+        </p:nvSpPr>
+        <p:spPr>
+          <a:xfrm>
+            <a:off x="704088" y="4014215"/>
+            <a:ext cx="338328" cy="338328"/>
+          </a:xfrm>
+          <a:prstGeom prst="roundRect">
+            <a:avLst/>
+          </a:prstGeom>
+          <a:solidFill>
+            <a:srgbClr val="25A99A"/>
+          </a:solidFill>
+          <a:ln>
+            <a:noFill/>
+          </a:ln>
+        </p:spPr>
+        <p:style>
+          <a:lnRef idx="1">
+            <a:schemeClr val="accent1"/>
+          </a:lnRef>
+          <a:fillRef idx="3">
+            <a:schemeClr val="accent1"/>
+          </a:fillRef>
+          <a:effectRef idx="2">
+            <a:schemeClr val="accent1"/>
+          </a:effectRef>
+          <a:fontRef idx="minor">
+            <a:schemeClr val="lt1"/>
+          </a:fontRef>
+        </p:style>
+        <p:txBody>
+          <a:bodyPr rtlCol="0" anchor="ctr"/>
+          <a:lstStyle/>
+          <a:p>
+            <a:pPr algn="ctr"/>
+          </a:p>
+        </p:txBody>
+      </p:sp>
+      <p:sp>
+        <p:nvSpPr>
+          <p:cNvPr id="13" name="TextBox 12"/>
+          <p:cNvSpPr txBox="1"/>
+          <p:nvPr/>
+        </p:nvSpPr>
+        <p:spPr>
+          <a:xfrm>
+            <a:off x="704088" y="4069079"/>
+            <a:ext cx="338328" cy="182880"/>
+          </a:xfrm>
+          <a:prstGeom prst="rect">
+            <a:avLst/>
+          </a:prstGeom>
+          <a:noFill/>
+        </p:spPr>
+        <p:txBody>
+          <a:bodyPr wrap="square" lIns="0" rIns="0" tIns="0" bIns="0">
+            <a:spAutoFit/>
+          </a:bodyPr>
+          <a:lstStyle/>
+          <a:p>
+            <a:pPr algn="ctr">
+              <a:defRPr sz="800" b="1">
+                <a:solidFill>
+                  <a:srgbClr val="FFFFFF"/>
+                </a:solidFill>
+                <a:latin typeface="Aptos"/>
+              </a:defRPr>
+            </a:pPr>
+            <a:r>
+              <a:t>03</a:t>
+            </a:r>
+          </a:p>
+        </p:txBody>
+      </p:sp>
+      <p:sp>
+        <p:nvSpPr>
+          <p:cNvPr id="14" name="TextBox 13"/>
+          <p:cNvSpPr txBox="1"/>
+          <p:nvPr/>
+        </p:nvSpPr>
+        <p:spPr>
+          <a:xfrm>
+            <a:off x="1243584" y="3977639"/>
+            <a:ext cx="5074920" cy="777240"/>
+          </a:xfrm>
+          <a:prstGeom prst="rect">
+            <a:avLst/>
+          </a:prstGeom>
+          <a:noFill/>
+        </p:spPr>
+        <p:txBody>
+          <a:bodyPr wrap="square" lIns="0" rIns="0" tIns="0" bIns="0">
+            <a:spAutoFit/>
+          </a:bodyPr>
+          <a:lstStyle/>
+          <a:p>
+            <a:pPr algn="l">
+              <a:defRPr sz="1500" b="0">
+                <a:solidFill>
+                  <a:srgbClr val="18313A"/>
+                </a:solidFill>
+                <a:latin typeface="Aptos"/>
+              </a:defRPr>
+            </a:pPr>
+            <a:r>
+              <a:t>Candidate match: a possible link that still needs an engineer’s review</a:t>
+            </a:r>
+          </a:p>
+        </p:txBody>
+      </p:sp>
+      <p:sp>
+        <p:nvSpPr>
+          <p:cNvPr id="15" name="Rounded Rectangle 14"/>
+          <p:cNvSpPr/>
+          <p:nvPr/>
+        </p:nvSpPr>
+        <p:spPr>
+          <a:xfrm>
+            <a:off x="704088" y="5038344"/>
+            <a:ext cx="338328" cy="338328"/>
+          </a:xfrm>
+          <a:prstGeom prst="roundRect">
+            <a:avLst/>
+          </a:prstGeom>
+          <a:solidFill>
+            <a:srgbClr val="25A99A"/>
+          </a:solidFill>
+          <a:ln>
+            <a:noFill/>
+          </a:ln>
+        </p:spPr>
+        <p:style>
+          <a:lnRef idx="1">
+            <a:schemeClr val="accent1"/>
+          </a:lnRef>
+          <a:fillRef idx="3">
+            <a:schemeClr val="accent1"/>
+          </a:fillRef>
+          <a:effectRef idx="2">
+            <a:schemeClr val="accent1"/>
+          </a:effectRef>
+          <a:fontRef idx="minor">
+            <a:schemeClr val="lt1"/>
+          </a:fontRef>
+        </p:style>
+        <p:txBody>
+          <a:bodyPr rtlCol="0" anchor="ctr"/>
+          <a:lstStyle/>
+          <a:p>
+            <a:pPr algn="ctr"/>
+          </a:p>
+        </p:txBody>
+      </p:sp>
+      <p:sp>
+        <p:nvSpPr>
+          <p:cNvPr id="16" name="TextBox 15"/>
+          <p:cNvSpPr txBox="1"/>
+          <p:nvPr/>
+        </p:nvSpPr>
+        <p:spPr>
+          <a:xfrm>
+            <a:off x="704088" y="5093208"/>
+            <a:ext cx="338328" cy="182880"/>
+          </a:xfrm>
+          <a:prstGeom prst="rect">
+            <a:avLst/>
+          </a:prstGeom>
+          <a:noFill/>
+        </p:spPr>
+        <p:txBody>
+          <a:bodyPr wrap="square" lIns="0" rIns="0" tIns="0" bIns="0">
+            <a:spAutoFit/>
+          </a:bodyPr>
+          <a:lstStyle/>
+          <a:p>
+            <a:pPr algn="ctr">
+              <a:defRPr sz="800" b="1">
+                <a:solidFill>
+                  <a:srgbClr val="FFFFFF"/>
+                </a:solidFill>
+                <a:latin typeface="Aptos"/>
+              </a:defRPr>
+            </a:pPr>
+            <a:r>
+              <a:t>04</a:t>
+            </a:r>
+          </a:p>
+        </p:txBody>
+      </p:sp>
+      <p:sp>
+        <p:nvSpPr>
+          <p:cNvPr id="17" name="TextBox 16"/>
+          <p:cNvSpPr txBox="1"/>
+          <p:nvPr/>
+        </p:nvSpPr>
+        <p:spPr>
+          <a:xfrm>
+            <a:off x="1243584" y="5001768"/>
+            <a:ext cx="5074920" cy="777240"/>
+          </a:xfrm>
+          <a:prstGeom prst="rect">
+            <a:avLst/>
+          </a:prstGeom>
+          <a:noFill/>
+        </p:spPr>
+        <p:txBody>
+          <a:bodyPr wrap="square" lIns="0" rIns="0" tIns="0" bIns="0">
+            <a:spAutoFit/>
+          </a:bodyPr>
+          <a:lstStyle/>
+          <a:p>
+            <a:pPr algn="l">
+              <a:defRPr sz="1500" b="0">
+                <a:solidFill>
+                  <a:srgbClr val="18313A"/>
+                </a:solidFill>
+                <a:latin typeface="Aptos"/>
+              </a:defRPr>
+            </a:pPr>
+            <a:r>
+              <a:t>Evidence: a record that supports a human decision</a:t>
+            </a:r>
+          </a:p>
+        </p:txBody>
+      </p:sp>
+      <p:sp>
+        <p:nvSpPr>
+          <p:cNvPr id="18" name="Rounded Rectangle 17"/>
+          <p:cNvSpPr/>
+          <p:nvPr/>
+        </p:nvSpPr>
+        <p:spPr>
+          <a:xfrm>
+            <a:off x="6812280" y="1664208"/>
+            <a:ext cx="4800600" cy="4279392"/>
+          </a:xfrm>
+          <a:prstGeom prst="roundRect">
+            <a:avLst/>
+          </a:prstGeom>
+          <a:solidFill>
+            <a:srgbClr val="1C3441"/>
+          </a:solidFill>
+          <a:ln>
+            <a:noFill/>
+          </a:ln>
+        </p:spPr>
+        <p:style>
+          <a:lnRef idx="1">
+            <a:schemeClr val="accent1"/>
+          </a:lnRef>
+          <a:fillRef idx="3">
+            <a:schemeClr val="accent1"/>
+          </a:fillRef>
+          <a:effectRef idx="2">
+            <a:schemeClr val="accent1"/>
+          </a:effectRef>
+          <a:fontRef idx="minor">
+            <a:schemeClr val="lt1"/>
+          </a:fontRef>
+        </p:style>
+        <p:txBody>
+          <a:bodyPr rtlCol="0" anchor="ctr"/>
+          <a:lstStyle/>
+          <a:p>
+            <a:pPr algn="ctr"/>
+          </a:p>
+        </p:txBody>
+      </p:sp>
+      <p:sp>
+        <p:nvSpPr>
+          <p:cNvPr id="19" name="TextBox 18"/>
+          <p:cNvSpPr txBox="1"/>
+          <p:nvPr/>
+        </p:nvSpPr>
+        <p:spPr>
+          <a:xfrm>
+            <a:off x="7086600" y="1920240"/>
+            <a:ext cx="4251960" cy="274320"/>
+          </a:xfrm>
+          <a:prstGeom prst="rect">
+            <a:avLst/>
+          </a:prstGeom>
+          <a:noFill/>
+        </p:spPr>
+        <p:txBody>
+          <a:bodyPr wrap="square" lIns="0" rIns="0" tIns="0" bIns="0">
+            <a:spAutoFit/>
+          </a:bodyPr>
+          <a:lstStyle/>
+          <a:p>
+            <a:pPr algn="l">
+              <a:defRPr sz="800" b="1">
+                <a:solidFill>
+                  <a:srgbClr val="8FC7BE"/>
+                </a:solidFill>
+                <a:latin typeface="Aptos"/>
+              </a:defRPr>
+            </a:pPr>
+            <a:r>
+              <a:t>OTPROOF / FIELD VIEW</a:t>
+            </a:r>
+          </a:p>
+        </p:txBody>
+      </p:sp>
+      <p:sp>
+        <p:nvSpPr>
+          <p:cNvPr id="20" name="TextBox 19"/>
+          <p:cNvSpPr txBox="1"/>
+          <p:nvPr/>
+        </p:nvSpPr>
+        <p:spPr>
+          <a:xfrm>
+            <a:off x="7150608" y="2414016"/>
+            <a:ext cx="4123944" cy="713232"/>
+          </a:xfrm>
+          <a:prstGeom prst="rect">
+            <a:avLst/>
+          </a:prstGeom>
+          <a:noFill/>
+        </p:spPr>
+        <p:txBody>
+          <a:bodyPr wrap="square" lIns="0" rIns="0" tIns="0" bIns="0">
+            <a:spAutoFit/>
+          </a:bodyPr>
+          <a:lstStyle/>
+          <a:p>
+            <a:pPr algn="l">
+              <a:defRPr sz="2900" b="1">
+                <a:solidFill>
+                  <a:srgbClr val="8FE0CE"/>
+                </a:solidFill>
+                <a:latin typeface="Aptos"/>
+              </a:defRPr>
+            </a:pPr>
+            <a:r>
+              <a:t>KEY TERMS</a:t>
+            </a:r>
+          </a:p>
+        </p:txBody>
+      </p:sp>
+      <p:sp>
+        <p:nvSpPr>
+          <p:cNvPr id="21" name="TextBox 20"/>
+          <p:cNvSpPr txBox="1"/>
+          <p:nvPr/>
+        </p:nvSpPr>
+        <p:spPr>
+          <a:xfrm>
+            <a:off x="7150608" y="3136392"/>
+            <a:ext cx="4123944" cy="548640"/>
+          </a:xfrm>
+          <a:prstGeom prst="rect">
+            <a:avLst/>
+          </a:prstGeom>
+          <a:noFill/>
+        </p:spPr>
+        <p:txBody>
+          <a:bodyPr wrap="square" lIns="0" rIns="0" tIns="0" bIns="0">
+            <a:spAutoFit/>
+          </a:bodyPr>
+          <a:lstStyle/>
+          <a:p>
+            <a:pPr algn="l">
+              <a:defRPr sz="1200" b="0">
+                <a:solidFill>
+                  <a:srgbClr val="D0E0DF"/>
+                </a:solidFill>
+                <a:latin typeface="Aptos"/>
+              </a:defRPr>
+            </a:pPr>
+            <a:r>
+              <a:t>Read the source and inventory record together</a:t>
+            </a:r>
+          </a:p>
+        </p:txBody>
+      </p:sp>
+      <p:sp>
+        <p:nvSpPr>
+          <p:cNvPr id="22" name="Rectangle 21"/>
+          <p:cNvSpPr/>
+          <p:nvPr/>
+        </p:nvSpPr>
+        <p:spPr>
+          <a:xfrm>
+            <a:off x="7178040" y="4014215"/>
+            <a:ext cx="109728" cy="109728"/>
+          </a:xfrm>
+          <a:prstGeom prst="rect">
+            <a:avLst/>
+          </a:prstGeom>
+          <a:solidFill>
+            <a:srgbClr val="25A99A"/>
+          </a:solidFill>
+          <a:ln>
+            <a:noFill/>
+          </a:ln>
+        </p:spPr>
+        <p:style>
+          <a:lnRef idx="1">
+            <a:schemeClr val="accent1"/>
+          </a:lnRef>
+          <a:fillRef idx="3">
+            <a:schemeClr val="accent1"/>
+          </a:fillRef>
+          <a:effectRef idx="2">
+            <a:schemeClr val="accent1"/>
+          </a:effectRef>
+          <a:fontRef idx="minor">
+            <a:schemeClr val="lt1"/>
+          </a:fontRef>
+        </p:style>
+        <p:txBody>
+          <a:bodyPr rtlCol="0" anchor="ctr"/>
+          <a:lstStyle/>
+          <a:p>
+            <a:pPr algn="ctr"/>
+          </a:p>
+        </p:txBody>
+      </p:sp>
+      <p:sp>
+        <p:nvSpPr>
+          <p:cNvPr id="23" name="TextBox 22"/>
+          <p:cNvSpPr txBox="1"/>
+          <p:nvPr/>
+        </p:nvSpPr>
+        <p:spPr>
+          <a:xfrm>
+            <a:off x="7415783" y="3968496"/>
+            <a:ext cx="3904487" cy="329184"/>
+          </a:xfrm>
+          <a:prstGeom prst="rect">
+            <a:avLst/>
+          </a:prstGeom>
+          <a:noFill/>
+        </p:spPr>
+        <p:txBody>
+          <a:bodyPr wrap="square" lIns="0" rIns="0" tIns="0" bIns="0">
+            <a:spAutoFit/>
+          </a:bodyPr>
+          <a:lstStyle/>
+          <a:p>
+            <a:pPr algn="l">
+              <a:defRPr sz="1000" b="0">
+                <a:solidFill>
+                  <a:srgbClr val="FFFFFF"/>
+                </a:solidFill>
+                <a:latin typeface="Aptos"/>
+              </a:defRPr>
+            </a:pPr>
+            <a:r>
+              <a:t>OT · computers and controllers for physical processes</a:t>
+            </a:r>
+          </a:p>
+        </p:txBody>
+      </p:sp>
+      <p:sp>
+        <p:nvSpPr>
+          <p:cNvPr id="24" name="Rectangle 23"/>
+          <p:cNvSpPr/>
+          <p:nvPr/>
+        </p:nvSpPr>
+        <p:spPr>
+          <a:xfrm>
+            <a:off x="7178040" y="4507992"/>
+            <a:ext cx="109728" cy="109728"/>
+          </a:xfrm>
+          <a:prstGeom prst="rect">
+            <a:avLst/>
+          </a:prstGeom>
+          <a:solidFill>
+            <a:srgbClr val="25A99A"/>
+          </a:solidFill>
+          <a:ln>
+            <a:noFill/>
+          </a:ln>
+        </p:spPr>
+        <p:style>
+          <a:lnRef idx="1">
+            <a:schemeClr val="accent1"/>
+          </a:lnRef>
+          <a:fillRef idx="3">
+            <a:schemeClr val="accent1"/>
+          </a:fillRef>
+          <a:effectRef idx="2">
+            <a:schemeClr val="accent1"/>
+          </a:effectRef>
+          <a:fontRef idx="minor">
+            <a:schemeClr val="lt1"/>
+          </a:fontRef>
+        </p:style>
+        <p:txBody>
+          <a:bodyPr rtlCol="0" anchor="ctr"/>
+          <a:lstStyle/>
+          <a:p>
+            <a:pPr algn="ctr"/>
+          </a:p>
+        </p:txBody>
+      </p:sp>
+      <p:sp>
+        <p:nvSpPr>
+          <p:cNvPr id="25" name="TextBox 24"/>
+          <p:cNvSpPr txBox="1"/>
+          <p:nvPr/>
+        </p:nvSpPr>
+        <p:spPr>
+          <a:xfrm>
+            <a:off x="7415783" y="4462272"/>
+            <a:ext cx="3904487" cy="329184"/>
+          </a:xfrm>
+          <a:prstGeom prst="rect">
+            <a:avLst/>
+          </a:prstGeom>
+          <a:noFill/>
+        </p:spPr>
+        <p:txBody>
+          <a:bodyPr wrap="square" lIns="0" rIns="0" tIns="0" bIns="0">
+            <a:spAutoFit/>
+          </a:bodyPr>
+          <a:lstStyle/>
+          <a:p>
+            <a:pPr algn="l">
+              <a:defRPr sz="1000" b="0">
+                <a:solidFill>
+                  <a:srgbClr val="FFFFFF"/>
+                </a:solidFill>
+                <a:latin typeface="Aptos"/>
+              </a:defRPr>
+            </a:pPr>
+            <a:r>
+              <a:t>CISA · U.S. Cybersecurity and Infrastructure Security Agency</a:t>
+            </a:r>
+          </a:p>
+        </p:txBody>
+      </p:sp>
+      <p:sp>
+        <p:nvSpPr>
+          <p:cNvPr id="26" name="Rectangle 25"/>
+          <p:cNvSpPr/>
+          <p:nvPr/>
+        </p:nvSpPr>
+        <p:spPr>
+          <a:xfrm>
+            <a:off x="7178040" y="5001768"/>
+            <a:ext cx="109728" cy="109728"/>
+          </a:xfrm>
+          <a:prstGeom prst="rect">
+            <a:avLst/>
+          </a:prstGeom>
+          <a:solidFill>
+            <a:srgbClr val="25A99A"/>
+          </a:solidFill>
+          <a:ln>
+            <a:noFill/>
+          </a:ln>
+        </p:spPr>
+        <p:style>
+          <a:lnRef idx="1">
+            <a:schemeClr val="accent1"/>
+          </a:lnRef>
+          <a:fillRef idx="3">
+            <a:schemeClr val="accent1"/>
+          </a:fillRef>
+          <a:effectRef idx="2">
+            <a:schemeClr val="accent1"/>
+          </a:effectRef>
+          <a:fontRef idx="minor">
+            <a:schemeClr val="lt1"/>
+          </a:fontRef>
+        </p:style>
+        <p:txBody>
+          <a:bodyPr rtlCol="0" anchor="ctr"/>
+          <a:lstStyle/>
+          <a:p>
+            <a:pPr algn="ctr"/>
+          </a:p>
+        </p:txBody>
+      </p:sp>
+      <p:sp>
+        <p:nvSpPr>
+          <p:cNvPr id="27" name="TextBox 26"/>
+          <p:cNvSpPr txBox="1"/>
+          <p:nvPr/>
+        </p:nvSpPr>
+        <p:spPr>
+          <a:xfrm>
+            <a:off x="7415783" y="4956048"/>
+            <a:ext cx="3904487" cy="329184"/>
+          </a:xfrm>
+          <a:prstGeom prst="rect">
+            <a:avLst/>
+          </a:prstGeom>
+          <a:noFill/>
+        </p:spPr>
+        <p:txBody>
+          <a:bodyPr wrap="square" lIns="0" rIns="0" tIns="0" bIns="0">
+            <a:spAutoFit/>
+          </a:bodyPr>
+          <a:lstStyle/>
+          <a:p>
+            <a:pPr algn="l">
+              <a:defRPr sz="1000" b="0">
+                <a:solidFill>
+                  <a:srgbClr val="FFFFFF"/>
+                </a:solidFill>
+                <a:latin typeface="Aptos"/>
+              </a:defRPr>
+            </a:pPr>
+            <a:r>
+              <a:t>CVE · public ID assigned to a specific vulnerability</a:t>
+            </a:r>
+          </a:p>
+        </p:txBody>
+      </p:sp>
+      <p:sp>
+        <p:nvSpPr>
+          <p:cNvPr id="28" name="Rectangle 27"/>
+          <p:cNvSpPr/>
+          <p:nvPr/>
+        </p:nvSpPr>
+        <p:spPr>
+          <a:xfrm>
+            <a:off x="7178040" y="5495544"/>
+            <a:ext cx="109728" cy="109728"/>
+          </a:xfrm>
+          <a:prstGeom prst="rect">
+            <a:avLst/>
+          </a:prstGeom>
+          <a:solidFill>
+            <a:srgbClr val="25A99A"/>
+          </a:solidFill>
+          <a:ln>
+            <a:noFill/>
+          </a:ln>
+        </p:spPr>
+        <p:style>
+          <a:lnRef idx="1">
+            <a:schemeClr val="accent1"/>
+          </a:lnRef>
+          <a:fillRef idx="3">
+            <a:schemeClr val="accent1"/>
+          </a:fillRef>
+          <a:effectRef idx="2">
+            <a:schemeClr val="accent1"/>
+          </a:effectRef>
+          <a:fontRef idx="minor">
+            <a:schemeClr val="lt1"/>
+          </a:fontRef>
+        </p:style>
+        <p:txBody>
+          <a:bodyPr rtlCol="0" anchor="ctr"/>
+          <a:lstStyle/>
+          <a:p>
+            <a:pPr algn="ctr"/>
+          </a:p>
+        </p:txBody>
+      </p:sp>
+      <p:sp>
+        <p:nvSpPr>
+          <p:cNvPr id="29" name="TextBox 28"/>
+          <p:cNvSpPr txBox="1"/>
+          <p:nvPr/>
+        </p:nvSpPr>
+        <p:spPr>
+          <a:xfrm>
+            <a:off x="7415783" y="5449824"/>
+            <a:ext cx="3904487" cy="329184"/>
+          </a:xfrm>
+          <a:prstGeom prst="rect">
+            <a:avLst/>
+          </a:prstGeom>
+          <a:noFill/>
+        </p:spPr>
+        <p:txBody>
+          <a:bodyPr wrap="square" lIns="0" rIns="0" tIns="0" bIns="0">
+            <a:spAutoFit/>
+          </a:bodyPr>
+          <a:lstStyle/>
+          <a:p>
+            <a:pPr algn="l">
+              <a:defRPr sz="1000" b="0">
+                <a:solidFill>
+                  <a:srgbClr val="FFFFFF"/>
+                </a:solidFill>
+                <a:latin typeface="Aptos"/>
+              </a:defRPr>
+            </a:pPr>
+            <a:r>
+              <a:t>KEV · CISA list of vulnerabilities known to be exploited</a:t>
+            </a:r>
+          </a:p>
+        </p:txBody>
+      </p:sp>
+      <p:sp>
+        <p:nvSpPr>
+          <p:cNvPr id="30" name="TextBox 29"/>
+          <p:cNvSpPr txBox="1"/>
+          <p:nvPr/>
+        </p:nvSpPr>
+        <p:spPr>
+          <a:xfrm>
+            <a:off x="676656" y="6327648"/>
+            <a:ext cx="10744200" cy="201168"/>
+          </a:xfrm>
+          <a:prstGeom prst="rect">
+            <a:avLst/>
+          </a:prstGeom>
+          <a:noFill/>
+        </p:spPr>
+        <p:txBody>
+          <a:bodyPr wrap="square" lIns="0" rIns="0" tIns="0" bIns="0">
+            <a:spAutoFit/>
+          </a:bodyPr>
+          <a:lstStyle/>
+          <a:p>
+            <a:pPr algn="l">
+              <a:defRPr sz="700" b="0">
+                <a:solidFill>
+                  <a:srgbClr val="63777C"/>
+                </a:solidFill>
+                <a:latin typeface="Aptos"/>
+              </a:defRPr>
+            </a:pPr>
+            <a:r>
+              <a:t>More terms and examples: README.md and OTProof_Technical_Design.md</a:t>
             </a:r>
           </a:p>
         </p:txBody>
@@ -10471,7 +11675,7 @@
               </a:defRPr>
             </a:pPr>
             <a:r>
-              <a:t>The review gap lives between two records</a:t>
+              <a:t>Why matching is harder than it looks</a:t>
             </a:r>
           </a:p>
         </p:txBody>
@@ -10507,7 +11711,7 @@
               </a:defRPr>
             </a:pPr>
             <a:r>
-              <a:t>An advisory lists products and versions. An operator owns assets, maintenance context, and change decisions.</a:t>
+              <a:t>The security notice and the equipment list often describe the same product in different ways.</a:t>
             </a:r>
           </a:p>
         </p:txBody>
@@ -11410,7 +12614,7 @@
               </a:defRPr>
             </a:pPr>
             <a:r>
-              <a:t>Critical infrastructure needs cautious handling</a:t>
+              <a:t>Essential services need careful decisions</a:t>
             </a:r>
           </a:p>
         </p:txBody>
@@ -11446,7 +12650,7 @@
               </a:defRPr>
             </a:pPr>
             <a:r>
-              <a:t>Water, energy, oil and gas, and industrial operators balance security with continuity, safety, and maintenance constraints.</a:t>
+              <a:t>Industrial control technology helps run water, energy, and other services, so changes need engineering review.</a:t>
             </a:r>
           </a:p>
         </p:txBody>
@@ -12021,7 +13225,7 @@
               </a:defRPr>
             </a:pPr>
             <a:r>
-              <a:t>File-based inventory</a:t>
+              <a:t>Operator's inventory file</a:t>
             </a:r>
           </a:p>
         </p:txBody>
@@ -12100,7 +13304,7 @@
               </a:defRPr>
             </a:pPr>
             <a:r>
-              <a:t>Public source egress</a:t>
+              <a:t>Approved public websites</a:t>
             </a:r>
           </a:p>
         </p:txBody>
@@ -12349,7 +13553,7 @@
               </a:defRPr>
             </a:pPr>
             <a:r>
-              <a:t>One auditable workflow from import to assurance</a:t>
+              <a:t>From import to report: six clear steps</a:t>
             </a:r>
           </a:p>
         </p:txBody>
@@ -12385,7 +13589,7 @@
               </a:defRPr>
             </a:pPr>
             <a:r>
-              <a:t>A repeatable sequence connects a source statement to an engineering decision and evidence record.</a:t>
+              <a:t>Follow the notice, compare the equipment, record the people’s decisions, and save the evidence.</a:t>
             </a:r>
           </a:p>
         </p:txBody>
@@ -12500,7 +13704,7 @@
               </a:defRPr>
             </a:pPr>
             <a:r>
-              <a:t>Validate inventory and import approved public advisory data</a:t>
+              <a:t>Check the equipment file and load public security notices</a:t>
             </a:r>
           </a:p>
         </p:txBody>
@@ -12615,7 +13819,7 @@
               </a:defRPr>
             </a:pPr>
             <a:r>
-              <a:t>Compare vendor, product, configuration, and version constraints</a:t>
+              <a:t>Compare maker, product, model, and installed version</a:t>
             </a:r>
           </a:p>
         </p:txBody>
@@ -12730,7 +13934,7 @@
               </a:defRPr>
             </a:pPr>
             <a:r>
-              <a:t>Record review, ticket approval, evidence, and verification</a:t>
+              <a:t>Record decisions, work approval, and supporting evidence</a:t>
             </a:r>
           </a:p>
         </p:txBody>
@@ -13820,7 +15024,7 @@
               </a:defRPr>
             </a:pPr>
             <a:r>
-              <a:t>FactoryTalk View SE 13.0.0 → applicable candidate</a:t>
+              <a:t>FactoryTalk View SE 13.0.0 → possible match</a:t>
             </a:r>
           </a:p>
         </p:txBody>
@@ -14201,7 +15405,7 @@
               </a:defRPr>
             </a:pPr>
             <a:r>
-              <a:t>CISA · published 13 Aug 2024 · updated 29 Aug 2024</a:t>
+              <a:t>CISA notice · published 13 Aug 2024 · updated 29 Aug 2024</a:t>
             </a:r>
           </a:p>
         </p:txBody>
@@ -14608,7 +15812,7 @@
               </a:defRPr>
             </a:pPr>
             <a:r>
-              <a:t>Deterministic matching earns each conclusion</a:t>
+              <a:t>No unsupported guesses: show the matching rules</a:t>
             </a:r>
           </a:p>
         </p:txBody>
@@ -14644,7 +15848,7 @@
               </a:defRPr>
             </a:pPr>
             <a:r>
-              <a:t>A small ruleset handles explicit source evidence; unsupported cases abstain.</a:t>
+              <a:t>Compare exact product and version details. If the records are incomplete, ask a person to check.</a:t>
             </a:r>
           </a:p>
         </p:txBody>
@@ -14759,7 +15963,7 @@
               </a:defRPr>
             </a:pPr>
             <a:r>
-              <a:t>Normalize only curated vendor and product aliases</a:t>
+              <a:t>Correct only known spelling variations</a:t>
             </a:r>
           </a:p>
         </p:txBody>
@@ -14874,7 +16078,7 @@
               </a:defRPr>
             </a:pPr>
             <a:r>
-              <a:t>Apply explicit equality and inclusive/exclusive version bounds</a:t>
+              <a:t>Compare the installed version with the notice’s affected version or range</a:t>
             </a:r>
           </a:p>
         </p:txBody>
@@ -14989,7 +16193,7 @@
               </a:defRPr>
             </a:pPr>
             <a:r>
-              <a:t>Route ambiguity, stale data, duplicates, and unknown syntax to review</a:t>
+              <a:t>Send missing, old, duplicate, or unclear records to human review</a:t>
             </a:r>
           </a:p>
         </p:txBody>
@@ -15219,7 +16423,7 @@
               </a:defRPr>
             </a:pPr>
             <a:r>
-              <a:t>Exact identity</a:t>
+              <a:t>Product names match</a:t>
             </a:r>
           </a:p>
         </p:txBody>
@@ -15298,7 +16502,7 @@
               </a:defRPr>
             </a:pPr>
             <a:r>
-              <a:t>Published constraint</a:t>
+              <a:t>Version fits the notice</a:t>
             </a:r>
           </a:p>
         </p:txBody>
@@ -15377,7 +16581,7 @@
               </a:defRPr>
             </a:pPr>
             <a:r>
-              <a:t>Traceable rationale</a:t>
+              <a:t>Reason and source link shown</a:t>
             </a:r>
           </a:p>
         </p:txBody>
@@ -15547,7 +16751,7 @@
               </a:defRPr>
             </a:pPr>
             <a:r>
-              <a:t>AI reads advisory text; people decide</a:t>
+              <a:t>AI can read; people make the decisions</a:t>
             </a:r>
           </a:p>
         </p:txBody>
@@ -15583,7 +16787,7 @@
               </a:defRPr>
             </a:pPr>
             <a:r>
-              <a:t>The local model is an optional extraction assistant behind schema and source checks.</a:t>
+              <a:t>An optional local AI helper suggests details from a notice. It cannot decide whether equipment is affected.</a:t>
             </a:r>
           </a:p>
         </p:txBody>
@@ -15698,7 +16902,7 @@
               </a:defRPr>
             </a:pPr>
             <a:r>
-              <a:t>Draft structured vendor, product, CVE, version, and mitigation fields</a:t>
+              <a:t>Suggest product, version, vulnerability ID, and mitigation details</a:t>
             </a:r>
           </a:p>
         </p:txBody>
@@ -15813,7 +17017,7 @@
               </a:defRPr>
             </a:pPr>
             <a:r>
-              <a:t>Treat embedded advisory instructions as untrusted text</a:t>
+              <a:t>Check suggested quotes and details against the original notice</a:t>
             </a:r>
           </a:p>
         </p:txBody>
@@ -15928,7 +17132,7 @@
               </a:defRPr>
             </a:pPr>
             <a:r>
-              <a:t>Keep model output out of applicability and remediation state</a:t>
+              <a:t>Never let AI approve work or mark equipment fixed</a:t>
             </a:r>
           </a:p>
         </p:txBody>
@@ -16079,7 +17283,7 @@
               </a:defRPr>
             </a:pPr>
             <a:r>
-              <a:t>Local Ollama adapter · no inference run in evaluation</a:t>
+              <a:t>Optional local AI · not run in evaluation</a:t>
             </a:r>
           </a:p>
         </p:txBody>
@@ -16158,7 +17362,7 @@
               </a:defRPr>
             </a:pPr>
             <a:r>
-              <a:t>Pydantic schema</a:t>
+              <a:t>Required fields checked</a:t>
             </a:r>
           </a:p>
         </p:txBody>
@@ -16237,7 +17441,7 @@
               </a:defRPr>
             </a:pPr>
             <a:r>
-              <a:t>Verbatim source evidence</a:t>
+              <a:t>Source details compared</a:t>
             </a:r>
           </a:p>
         </p:txBody>
@@ -16352,7 +17556,7 @@
               </a:defRPr>
             </a:pPr>
             <a:r>
-              <a:t>Optional Qwen2.5 7B Instruct model; Apache-2.0 model repo. No weights included.</a:t>
+              <a:t>Optional local model; no model weights included and no inference run in evaluation.</a:t>
             </a:r>
           </a:p>
         </p:txBody>
@@ -16486,7 +17690,7 @@
               </a:defRPr>
             </a:pPr>
             <a:r>
-              <a:t>A compact architecture keeps evidence close to the decision</a:t>
+              <a:t>How the software is put together</a:t>
             </a:r>
           </a:p>
         </p:txBody>
@@ -16522,7 +17726,7 @@
               </a:defRPr>
             </a:pPr>
             <a:r>
-              <a:t>A modular monolith is easier to inspect and package for a controlled first pilot.</a:t>
+              <a:t>A web page, one service, and a database keep the process simple to inspect and run.</a:t>
             </a:r>
           </a:p>
         </p:txBody>
@@ -16637,7 +17841,7 @@
               </a:defRPr>
             </a:pPr>
             <a:r>
-              <a:t>React + TypeScript dashboard, FastAPI + Pydantic service</a:t>
+              <a:t>Web dashboard and a service that checks and compares records</a:t>
             </a:r>
           </a:p>
         </p:txBody>
@@ -16752,7 +17956,7 @@
               </a:defRPr>
             </a:pPr>
             <a:r>
-              <a:t>PostgreSQL deployment; SQLite for local offline demonstration</a:t>
+              <a:t>Database for decisions; PDF and JSON reports for handoff</a:t>
             </a:r>
           </a:p>
         </p:txBody>
@@ -16867,7 +18071,7 @@
               </a:defRPr>
             </a:pPr>
             <a:r>
-              <a:t>Cached public sources, deterministic matcher, audit and report services</a:t>
+              <a:t>Optional AI helper runs locally and only drafts suggestions</a:t>
             </a:r>
           </a:p>
         </p:txBody>
@@ -17025,7 +18229,7 @@
               </a:defRPr>
             </a:pPr>
             <a:r>
-              <a:t>INVENTORY + SOURCES</a:t>
+              <a:t>INVENTORY + NOTICES</a:t>
             </a:r>
           </a:p>
         </p:txBody>
@@ -17104,7 +18308,7 @@
               </a:defRPr>
             </a:pPr>
             <a:r>
-              <a:t>VALIDATION + CACHE</a:t>
+              <a:t>CHECK + SAVE</a:t>
             </a:r>
           </a:p>
         </p:txBody>
@@ -17183,7 +18387,7 @@
               </a:defRPr>
             </a:pPr>
             <a:r>
-              <a:t>MATCH + WORKFLOW</a:t>
+              <a:t>MATCH + REVIEW</a:t>
             </a:r>
           </a:p>
         </p:txBody>
@@ -17262,7 +18466,7 @@
               </a:defRPr>
             </a:pPr>
             <a:r>
-              <a:t>REPORT + AUDIT</a:t>
+              <a:t>DASHBOARD + REPORT</a:t>
             </a:r>
           </a:p>
         </p:txBody>
@@ -17368,7 +18572,7 @@
               </a:defRPr>
             </a:pPr>
             <a:r>
-              <a:t>OPTIONAL LOCAL LLM · suggestion only</a:t>
+              <a:t>OPTIONAL LOCAL AI · suggestion only</a:t>
             </a:r>
           </a:p>
         </p:txBody>
@@ -17538,7 +18742,7 @@
               </a:defRPr>
             </a:pPr>
             <a:r>
-              <a:t>From finding to verified evidence</a:t>
+              <a:t>People own every decision</a:t>
             </a:r>
           </a:p>
         </p:txBody>
@@ -17574,7 +18778,7 @@
               </a:defRPr>
             </a:pPr>
             <a:r>
-              <a:t>Role separation prevents generated text or a proposed ticket from becoming a remediation claim.</a:t>
+              <a:t>A review, a work plan, approval, and proof of completed work are separate steps.</a:t>
             </a:r>
           </a:p>
         </p:txBody>
@@ -18422,7 +19626,7 @@
               </a:defRPr>
             </a:pPr>
             <a:r>
-              <a:t>Demo bearer tokens are public; production identity integration is required.</a:t>
+              <a:t>Demo passwords are visible; company login is needed before real use.</a:t>
             </a:r>
           </a:p>
         </p:txBody>

</xml_diff>